<commit_message>
fix: align slide titles 100% with template and pass all TDD tests
</commit_message>
<xml_diff>
--- a/AegisMAS_Capstone_Proposal.pptx
+++ b/AegisMAS_Capstone_Proposal.pptx
@@ -5061,7 +5061,7 @@
                 </a:solidFill>
                 <a:latin typeface="Trebuchet MS"/>
               </a:rPr>
-              <a:t>Presentation Outline</a:t>
+              <a:t>Outline</a:t>
             </a:r>
           </a:p>
         </p:txBody>
@@ -5853,7 +5853,7 @@
                 </a:solidFill>
                 <a:latin typeface="Trebuchet MS"/>
               </a:rPr>
-              <a:t>Scope and Feasibility Study</a:t>
+              <a:t>Scope and Feasibility study</a:t>
             </a:r>
             <a:endParaRPr lang="en-US" sz="2400" dirty="0">
               <a:solidFill>
@@ -6217,7 +6217,7 @@
                 </a:solidFill>
                 <a:latin typeface="Trebuchet MS"/>
               </a:rPr>
-              <a:t>Background Work &amp; Domain Context</a:t>
+              <a:t>Background</a:t>
             </a:r>
             <a:endParaRPr lang="en-US" sz="2400" dirty="0">
               <a:solidFill>
@@ -6739,7 +6739,7 @@
                 </a:solidFill>
                 <a:latin typeface="Trebuchet MS"/>
               </a:rPr>
-              <a:t>Real-World Applications &amp; Use Cases</a:t>
+              <a:t>Applications/Use cases</a:t>
             </a:r>
             <a:endParaRPr lang="en-US" sz="2400" dirty="0">
               <a:solidFill>
@@ -6903,7 +6903,7 @@
                 </a:solidFill>
                 <a:latin typeface="Trebuchet MS"/>
               </a:rPr>
-              <a:t>Expected Deliverables by Phase</a:t>
+              <a:t>Expected Deliverables</a:t>
             </a:r>
             <a:endParaRPr lang="en-US" sz="2400" dirty="0"/>
           </a:p>
@@ -7270,7 +7270,7 @@
                 </a:solidFill>
                 <a:latin typeface="Trebuchet MS"/>
               </a:rPr>
-              <a:t>16-Week Project Timeline &amp; Team Effort</a:t>
+              <a:t>Capstone (Phase-I &amp; Phase-II) Project Timeline</a:t>
             </a:r>
             <a:endParaRPr lang="en-US" sz="2400" dirty="0">
               <a:solidFill>
@@ -9479,7 +9479,7 @@
                 </a:solidFill>
                 <a:latin typeface="Trebuchet MS"/>
               </a:rPr>
-              <a:t>Proposed Methodology: AegisMAS Defense-in-Depth</a:t>
+              <a:t>Any other information: Proposed Methodology</a:t>
             </a:r>
           </a:p>
         </p:txBody>

</xml_diff>